<commit_message>
feat: PPT 大纲（json+md）、B/C 两版可编辑 PPT 与两个高 star PPT skill 推荐
Co-authored-by: arena-agent <297053741+arena-agent@users.noreply.github.com>
</commit_message>
<xml_diff>
--- a/deliverable/中期答辩.pptx
+++ b/deliverable/中期答辩.pptx
@@ -120,6 +120,1476 @@
     </a:lvl9pPr>
   </p:defaultTextStyle>
 </p:presentation>
+</file>
+
+<file path=ppt/notesMasters/notesMaster1.xml><?xml version="1.0" encoding="utf-8"?>
+<p:notesMaster xmlns:a="http://schemas.openxmlformats.org/drawingml/2006/main" xmlns:p="http://schemas.openxmlformats.org/presentationml/2006/main" xmlns:r="http://schemas.openxmlformats.org/officeDocument/2006/relationships">
+  <p:cSld>
+    <p:bg>
+      <p:bgRef idx="1001">
+        <a:schemeClr val="bg1"/>
+      </p:bgRef>
+    </p:bg>
+    <p:spTree>
+      <p:nvGrpSpPr>
+        <p:cNvPr id="1" name=""/>
+        <p:cNvGrpSpPr/>
+        <p:nvPr/>
+      </p:nvGrpSpPr>
+      <p:grpSpPr>
+        <a:xfrm>
+          <a:off x="0" y="0"/>
+          <a:ext cx="0" cy="0"/>
+          <a:chOff x="0" y="0"/>
+          <a:chExt cx="0" cy="0"/>
+        </a:xfrm>
+      </p:grpSpPr>
+      <p:sp>
+        <p:nvSpPr>
+          <p:cNvPr id="2" name="Header Placeholder 1"/>
+          <p:cNvSpPr>
+            <a:spLocks noGrp="1"/>
+          </p:cNvSpPr>
+          <p:nvPr>
+            <p:ph type="hdr" sz="quarter"/>
+          </p:nvPr>
+        </p:nvSpPr>
+        <p:spPr>
+          <a:xfrm>
+            <a:off x="0" y="0"/>
+            <a:ext cx="2971800" cy="457200"/>
+          </a:xfrm>
+          <a:prstGeom prst="rect">
+            <a:avLst/>
+          </a:prstGeom>
+        </p:spPr>
+        <p:txBody>
+          <a:bodyPr vert="horz" lIns="91440" tIns="45720" rIns="91440" bIns="45720" rtlCol="0"/>
+          <a:lstStyle>
+            <a:lvl1pPr algn="l">
+              <a:defRPr sz="1200"/>
+            </a:lvl1pPr>
+          </a:lstStyle>
+          <a:p>
+            <a:endParaRPr lang="en-US"/>
+          </a:p>
+        </p:txBody>
+      </p:sp>
+      <p:sp>
+        <p:nvSpPr>
+          <p:cNvPr id="3" name="Date Placeholder 2"/>
+          <p:cNvSpPr>
+            <a:spLocks noGrp="1"/>
+          </p:cNvSpPr>
+          <p:nvPr>
+            <p:ph type="dt" idx="1"/>
+          </p:nvPr>
+        </p:nvSpPr>
+        <p:spPr>
+          <a:xfrm>
+            <a:off x="3884613" y="0"/>
+            <a:ext cx="2971800" cy="457200"/>
+          </a:xfrm>
+          <a:prstGeom prst="rect">
+            <a:avLst/>
+          </a:prstGeom>
+        </p:spPr>
+        <p:txBody>
+          <a:bodyPr vert="horz" lIns="91440" tIns="45720" rIns="91440" bIns="45720" rtlCol="0"/>
+          <a:lstStyle>
+            <a:lvl1pPr algn="r">
+              <a:defRPr sz="1200"/>
+            </a:lvl1pPr>
+          </a:lstStyle>
+          <a:p>
+            <a:fld id="{0F89C1C7-3DCD-1040-A9CF-14679D8B5DDD}" type="datetimeFigureOut">
+              <a:rPr lang="en-US" smtClean="0"/>
+              <a:t>10/17/16</a:t>
+            </a:fld>
+            <a:endParaRPr lang="en-US"/>
+          </a:p>
+        </p:txBody>
+      </p:sp>
+      <p:sp>
+        <p:nvSpPr>
+          <p:cNvPr id="4" name="Slide Image Placeholder 3"/>
+          <p:cNvSpPr>
+            <a:spLocks noGrp="1" noRot="1" noChangeAspect="1"/>
+          </p:cNvSpPr>
+          <p:nvPr>
+            <p:ph type="sldImg" idx="2"/>
+          </p:nvPr>
+        </p:nvSpPr>
+        <p:spPr>
+          <a:xfrm>
+            <a:off x="1143000" y="685800"/>
+            <a:ext cx="4572000" cy="3429000"/>
+          </a:xfrm>
+          <a:prstGeom prst="rect">
+            <a:avLst/>
+          </a:prstGeom>
+          <a:noFill/>
+          <a:ln w="12700">
+            <a:solidFill>
+              <a:prstClr val="black"/>
+            </a:solidFill>
+          </a:ln>
+        </p:spPr>
+        <p:txBody>
+          <a:bodyPr vert="horz" lIns="91440" tIns="45720" rIns="91440" bIns="45720" rtlCol="0" anchor="ctr"/>
+          <a:lstStyle/>
+          <a:p>
+            <a:endParaRPr lang="en-US"/>
+          </a:p>
+        </p:txBody>
+      </p:sp>
+      <p:sp>
+        <p:nvSpPr>
+          <p:cNvPr id="5" name="Notes Placeholder 4"/>
+          <p:cNvSpPr>
+            <a:spLocks noGrp="1"/>
+          </p:cNvSpPr>
+          <p:nvPr>
+            <p:ph type="body" sz="quarter" idx="3"/>
+          </p:nvPr>
+        </p:nvSpPr>
+        <p:spPr>
+          <a:xfrm>
+            <a:off x="685800" y="4343400"/>
+            <a:ext cx="5486400" cy="4114800"/>
+          </a:xfrm>
+          <a:prstGeom prst="rect">
+            <a:avLst/>
+          </a:prstGeom>
+        </p:spPr>
+        <p:txBody>
+          <a:bodyPr vert="horz" lIns="91440" tIns="45720" rIns="91440" bIns="45720" rtlCol="0"/>
+          <a:lstStyle/>
+          <a:p>
+            <a:pPr lvl="0"/>
+            <a:r>
+              <a:rPr lang="en-US" smtClean="0"/>
+              <a:t>Click to edit Master text styles</a:t>
+            </a:r>
+          </a:p>
+          <a:p>
+            <a:pPr lvl="1"/>
+            <a:r>
+              <a:rPr lang="en-US" smtClean="0"/>
+              <a:t>Second level</a:t>
+            </a:r>
+          </a:p>
+          <a:p>
+            <a:pPr lvl="2"/>
+            <a:r>
+              <a:rPr lang="en-US" smtClean="0"/>
+              <a:t>Third level</a:t>
+            </a:r>
+          </a:p>
+          <a:p>
+            <a:pPr lvl="3"/>
+            <a:r>
+              <a:rPr lang="en-US" smtClean="0"/>
+              <a:t>Fourth level</a:t>
+            </a:r>
+          </a:p>
+          <a:p>
+            <a:pPr lvl="4"/>
+            <a:r>
+              <a:rPr lang="en-US" smtClean="0"/>
+              <a:t>Fifth level</a:t>
+            </a:r>
+            <a:endParaRPr lang="en-US"/>
+          </a:p>
+        </p:txBody>
+      </p:sp>
+      <p:sp>
+        <p:nvSpPr>
+          <p:cNvPr id="6" name="Footer Placeholder 5"/>
+          <p:cNvSpPr>
+            <a:spLocks noGrp="1"/>
+          </p:cNvSpPr>
+          <p:nvPr>
+            <p:ph type="ftr" sz="quarter" idx="4"/>
+          </p:nvPr>
+        </p:nvSpPr>
+        <p:spPr>
+          <a:xfrm>
+            <a:off x="0" y="8685213"/>
+            <a:ext cx="2971800" cy="457200"/>
+          </a:xfrm>
+          <a:prstGeom prst="rect">
+            <a:avLst/>
+          </a:prstGeom>
+        </p:spPr>
+        <p:txBody>
+          <a:bodyPr vert="horz" lIns="91440" tIns="45720" rIns="91440" bIns="45720" rtlCol="0" anchor="b"/>
+          <a:lstStyle>
+            <a:lvl1pPr algn="l">
+              <a:defRPr sz="1200"/>
+            </a:lvl1pPr>
+          </a:lstStyle>
+          <a:p>
+            <a:endParaRPr lang="en-US"/>
+          </a:p>
+        </p:txBody>
+      </p:sp>
+      <p:sp>
+        <p:nvSpPr>
+          <p:cNvPr id="7" name="Slide Number Placeholder 6"/>
+          <p:cNvSpPr>
+            <a:spLocks noGrp="1"/>
+          </p:cNvSpPr>
+          <p:nvPr>
+            <p:ph type="sldNum" sz="quarter" idx="5"/>
+          </p:nvPr>
+        </p:nvSpPr>
+        <p:spPr>
+          <a:xfrm>
+            <a:off x="3884613" y="8685213"/>
+            <a:ext cx="2971800" cy="457200"/>
+          </a:xfrm>
+          <a:prstGeom prst="rect">
+            <a:avLst/>
+          </a:prstGeom>
+        </p:spPr>
+        <p:txBody>
+          <a:bodyPr vert="horz" lIns="91440" tIns="45720" rIns="91440" bIns="45720" rtlCol="0" anchor="b"/>
+          <a:lstStyle>
+            <a:lvl1pPr algn="r">
+              <a:defRPr sz="1200"/>
+            </a:lvl1pPr>
+          </a:lstStyle>
+          <a:p>
+            <a:fld id="{BB5E49A5-4136-284D-997B-48E1D791AD67}" type="slidenum">
+              <a:rPr lang="en-US" smtClean="0"/>
+              <a:t>‹#›</a:t>
+            </a:fld>
+            <a:endParaRPr lang="en-US"/>
+          </a:p>
+        </p:txBody>
+      </p:sp>
+    </p:spTree>
+    <p:extLst>
+      <p:ext uri="{BB962C8B-B14F-4D97-AF65-F5344CB8AC3E}">
+        <p14:creationId xmlns:p14="http://schemas.microsoft.com/office/powerpoint/2010/main" val="2623252185"/>
+      </p:ext>
+    </p:extLst>
+  </p:cSld>
+  <p:clrMap bg1="lt1" tx1="dk1" bg2="lt2" tx2="dk2" accent1="accent1" accent2="accent2" accent3="accent3" accent4="accent4" accent5="accent5" accent6="accent6" hlink="hlink" folHlink="folHlink"/>
+  <p:notesStyle>
+    <a:lvl1pPr marL="0" algn="l" defTabSz="457200" rtl="0" eaLnBrk="1" latinLnBrk="0" hangingPunct="1">
+      <a:defRPr sz="1200" kern="1200">
+        <a:solidFill>
+          <a:schemeClr val="tx1"/>
+        </a:solidFill>
+        <a:latin typeface="+mn-lt"/>
+        <a:ea typeface="+mn-ea"/>
+        <a:cs typeface="+mn-cs"/>
+      </a:defRPr>
+    </a:lvl1pPr>
+    <a:lvl2pPr marL="457200" algn="l" defTabSz="457200" rtl="0" eaLnBrk="1" latinLnBrk="0" hangingPunct="1">
+      <a:defRPr sz="1200" kern="1200">
+        <a:solidFill>
+          <a:schemeClr val="tx1"/>
+        </a:solidFill>
+        <a:latin typeface="+mn-lt"/>
+        <a:ea typeface="+mn-ea"/>
+        <a:cs typeface="+mn-cs"/>
+      </a:defRPr>
+    </a:lvl2pPr>
+    <a:lvl3pPr marL="914400" algn="l" defTabSz="457200" rtl="0" eaLnBrk="1" latinLnBrk="0" hangingPunct="1">
+      <a:defRPr sz="1200" kern="1200">
+        <a:solidFill>
+          <a:schemeClr val="tx1"/>
+        </a:solidFill>
+        <a:latin typeface="+mn-lt"/>
+        <a:ea typeface="+mn-ea"/>
+        <a:cs typeface="+mn-cs"/>
+      </a:defRPr>
+    </a:lvl3pPr>
+    <a:lvl4pPr marL="1371600" algn="l" defTabSz="457200" rtl="0" eaLnBrk="1" latinLnBrk="0" hangingPunct="1">
+      <a:defRPr sz="1200" kern="1200">
+        <a:solidFill>
+          <a:schemeClr val="tx1"/>
+        </a:solidFill>
+        <a:latin typeface="+mn-lt"/>
+        <a:ea typeface="+mn-ea"/>
+        <a:cs typeface="+mn-cs"/>
+      </a:defRPr>
+    </a:lvl4pPr>
+    <a:lvl5pPr marL="1828800" algn="l" defTabSz="457200" rtl="0" eaLnBrk="1" latinLnBrk="0" hangingPunct="1">
+      <a:defRPr sz="1200" kern="1200">
+        <a:solidFill>
+          <a:schemeClr val="tx1"/>
+        </a:solidFill>
+        <a:latin typeface="+mn-lt"/>
+        <a:ea typeface="+mn-ea"/>
+        <a:cs typeface="+mn-cs"/>
+      </a:defRPr>
+    </a:lvl5pPr>
+    <a:lvl6pPr marL="2286000" algn="l" defTabSz="457200" rtl="0" eaLnBrk="1" latinLnBrk="0" hangingPunct="1">
+      <a:defRPr sz="1200" kern="1200">
+        <a:solidFill>
+          <a:schemeClr val="tx1"/>
+        </a:solidFill>
+        <a:latin typeface="+mn-lt"/>
+        <a:ea typeface="+mn-ea"/>
+        <a:cs typeface="+mn-cs"/>
+      </a:defRPr>
+    </a:lvl6pPr>
+    <a:lvl7pPr marL="2743200" algn="l" defTabSz="457200" rtl="0" eaLnBrk="1" latinLnBrk="0" hangingPunct="1">
+      <a:defRPr sz="1200" kern="1200">
+        <a:solidFill>
+          <a:schemeClr val="tx1"/>
+        </a:solidFill>
+        <a:latin typeface="+mn-lt"/>
+        <a:ea typeface="+mn-ea"/>
+        <a:cs typeface="+mn-cs"/>
+      </a:defRPr>
+    </a:lvl7pPr>
+    <a:lvl8pPr marL="3200400" algn="l" defTabSz="457200" rtl="0" eaLnBrk="1" latinLnBrk="0" hangingPunct="1">
+      <a:defRPr sz="1200" kern="1200">
+        <a:solidFill>
+          <a:schemeClr val="tx1"/>
+        </a:solidFill>
+        <a:latin typeface="+mn-lt"/>
+        <a:ea typeface="+mn-ea"/>
+        <a:cs typeface="+mn-cs"/>
+      </a:defRPr>
+    </a:lvl8pPr>
+    <a:lvl9pPr marL="3657600" algn="l" defTabSz="457200" rtl="0" eaLnBrk="1" latinLnBrk="0" hangingPunct="1">
+      <a:defRPr sz="1200" kern="1200">
+        <a:solidFill>
+          <a:schemeClr val="tx1"/>
+        </a:solidFill>
+        <a:latin typeface="+mn-lt"/>
+        <a:ea typeface="+mn-ea"/>
+        <a:cs typeface="+mn-cs"/>
+      </a:defRPr>
+    </a:lvl9pPr>
+  </p:notesStyle>
+</p:notesMaster>
+</file>
+
+<file path=ppt/notesSlides/notesSlide1.xml><?xml version="1.0" encoding="utf-8"?>
+<p:notes xmlns:a="http://schemas.openxmlformats.org/drawingml/2006/main" xmlns:p="http://schemas.openxmlformats.org/presentationml/2006/main" xmlns:r="http://schemas.openxmlformats.org/officeDocument/2006/relationships">
+  <p:cSld>
+    <p:spTree>
+      <p:nvGrpSpPr>
+        <p:cNvPr id="1" name=""/>
+        <p:cNvGrpSpPr/>
+        <p:nvPr/>
+      </p:nvGrpSpPr>
+      <p:grpSpPr>
+        <a:xfrm>
+          <a:off x="0" y="0"/>
+          <a:ext cx="0" cy="0"/>
+          <a:chOff x="0" y="0"/>
+          <a:chExt cx="0" cy="0"/>
+        </a:xfrm>
+      </p:grpSpPr>
+      <p:sp>
+        <p:nvSpPr>
+          <p:cNvPr id="2" name="Slide Image Placeholder 1"/>
+          <p:cNvSpPr>
+            <a:spLocks noGrp="1"/>
+          </p:cNvSpPr>
+          <p:nvPr>
+            <p:ph type="sldImg" idx="2"/>
+          </p:nvPr>
+        </p:nvSpPr>
+        <p:spPr/>
+      </p:sp>
+      <p:sp>
+        <p:nvSpPr>
+          <p:cNvPr id="3" name="Notes Placeholder 2"/>
+          <p:cNvSpPr>
+            <a:spLocks noGrp="1"/>
+          </p:cNvSpPr>
+          <p:nvPr>
+            <p:ph type="body" idx="3" sz="quarter"/>
+          </p:nvPr>
+        </p:nvSpPr>
+        <p:spPr/>
+        <p:txBody>
+          <a:bodyPr/>
+          <a:lstStyle/>
+          <a:p>
+            <a:r>
+              <a:t>各位老师好，我汇报的题目是《基于深度学习的阿尔茨海默症患者与健康人群肠道微生物组中抗菌肽的差异性研究》。本次中期检查按导师意见，重点汇报研究思路与各项工作的完成程度。</a:t>
+            </a:r>
+          </a:p>
+        </p:txBody>
+      </p:sp>
+      <p:sp>
+        <p:nvSpPr>
+          <p:cNvPr id="4" name="Slide Number Placeholder 3"/>
+          <p:cNvSpPr>
+            <a:spLocks noGrp="1"/>
+          </p:cNvSpPr>
+          <p:nvPr>
+            <p:ph type="sldNum" idx="5" sz="quarter"/>
+          </p:nvPr>
+        </p:nvSpPr>
+        <p:spPr/>
+      </p:sp>
+    </p:spTree>
+  </p:cSld>
+  <p:clrMapOvr>
+    <a:masterClrMapping/>
+  </p:clrMapOvr>
+</p:notes>
+</file>
+
+<file path=ppt/notesSlides/notesSlide10.xml><?xml version="1.0" encoding="utf-8"?>
+<p:notes xmlns:a="http://schemas.openxmlformats.org/drawingml/2006/main" xmlns:p="http://schemas.openxmlformats.org/presentationml/2006/main" xmlns:r="http://schemas.openxmlformats.org/officeDocument/2006/relationships">
+  <p:cSld>
+    <p:spTree>
+      <p:nvGrpSpPr>
+        <p:cNvPr id="1" name=""/>
+        <p:cNvGrpSpPr/>
+        <p:nvPr/>
+      </p:nvGrpSpPr>
+      <p:grpSpPr>
+        <a:xfrm>
+          <a:off x="0" y="0"/>
+          <a:ext cx="0" cy="0"/>
+          <a:chOff x="0" y="0"/>
+          <a:chExt cx="0" cy="0"/>
+        </a:xfrm>
+      </p:grpSpPr>
+      <p:sp>
+        <p:nvSpPr>
+          <p:cNvPr id="2" name="Slide Image Placeholder 1"/>
+          <p:cNvSpPr>
+            <a:spLocks noGrp="1"/>
+          </p:cNvSpPr>
+          <p:nvPr>
+            <p:ph type="sldImg" idx="2"/>
+          </p:nvPr>
+        </p:nvSpPr>
+        <p:spPr/>
+      </p:sp>
+      <p:sp>
+        <p:nvSpPr>
+          <p:cNvPr id="3" name="Notes Placeholder 2"/>
+          <p:cNvSpPr>
+            <a:spLocks noGrp="1"/>
+          </p:cNvSpPr>
+          <p:nvPr>
+            <p:ph type="body" idx="3" sz="quarter"/>
+          </p:nvPr>
+        </p:nvSpPr>
+        <p:spPr/>
+        <p:txBody>
+          <a:bodyPr/>
+          <a:lstStyle/>
+          <a:p>
+            <a:r>
+              <a:t>最后是抑菌实验验证，方案刻意做得很简单：选少量有代表性的候选肽送合成，用常见指示菌做纸片扩散法初筛，再用微量肉汤稀释法测最低抑菌浓度，同时设置阳性与阴性对照。常规微生物实验室即可完成。</a:t>
+            </a:r>
+          </a:p>
+        </p:txBody>
+      </p:sp>
+      <p:sp>
+        <p:nvSpPr>
+          <p:cNvPr id="4" name="Slide Number Placeholder 3"/>
+          <p:cNvSpPr>
+            <a:spLocks noGrp="1"/>
+          </p:cNvSpPr>
+          <p:nvPr>
+            <p:ph type="sldNum" idx="5" sz="quarter"/>
+          </p:nvPr>
+        </p:nvSpPr>
+        <p:spPr/>
+      </p:sp>
+    </p:spTree>
+  </p:cSld>
+  <p:clrMapOvr>
+    <a:masterClrMapping/>
+  </p:clrMapOvr>
+</p:notes>
+</file>
+
+<file path=ppt/notesSlides/notesSlide11.xml><?xml version="1.0" encoding="utf-8"?>
+<p:notes xmlns:a="http://schemas.openxmlformats.org/drawingml/2006/main" xmlns:p="http://schemas.openxmlformats.org/presentationml/2006/main" xmlns:r="http://schemas.openxmlformats.org/officeDocument/2006/relationships">
+  <p:cSld>
+    <p:spTree>
+      <p:nvGrpSpPr>
+        <p:cNvPr id="1" name=""/>
+        <p:cNvGrpSpPr/>
+        <p:nvPr/>
+      </p:nvGrpSpPr>
+      <p:grpSpPr>
+        <a:xfrm>
+          <a:off x="0" y="0"/>
+          <a:ext cx="0" cy="0"/>
+          <a:chOff x="0" y="0"/>
+          <a:chExt cx="0" cy="0"/>
+        </a:xfrm>
+      </p:grpSpPr>
+      <p:sp>
+        <p:nvSpPr>
+          <p:cNvPr id="2" name="Slide Image Placeholder 1"/>
+          <p:cNvSpPr>
+            <a:spLocks noGrp="1"/>
+          </p:cNvSpPr>
+          <p:nvPr>
+            <p:ph type="sldImg" idx="2"/>
+          </p:nvPr>
+        </p:nvSpPr>
+        <p:spPr/>
+      </p:sp>
+      <p:sp>
+        <p:nvSpPr>
+          <p:cNvPr id="3" name="Notes Placeholder 2"/>
+          <p:cNvSpPr>
+            <a:spLocks noGrp="1"/>
+          </p:cNvSpPr>
+          <p:nvPr>
+            <p:ph type="body" idx="3" sz="quarter"/>
+          </p:nvPr>
+        </p:nvSpPr>
+        <p:spPr/>
+        <p:txBody>
+          <a:bodyPr/>
+          <a:lstStyle/>
+          <a:p>
+            <a:r>
+              <a:t>从进度上看，前五项任务已经全部完成，目前集中在机制关联分析与抑菌实验验证两件事上，论文撰写同步推进，整体进度与开题安排一致。</a:t>
+            </a:r>
+          </a:p>
+        </p:txBody>
+      </p:sp>
+      <p:sp>
+        <p:nvSpPr>
+          <p:cNvPr id="4" name="Slide Number Placeholder 3"/>
+          <p:cNvSpPr>
+            <a:spLocks noGrp="1"/>
+          </p:cNvSpPr>
+          <p:nvPr>
+            <p:ph type="sldNum" idx="5" sz="quarter"/>
+          </p:nvPr>
+        </p:nvSpPr>
+        <p:spPr/>
+      </p:sp>
+    </p:spTree>
+  </p:cSld>
+  <p:clrMapOvr>
+    <a:masterClrMapping/>
+  </p:clrMapOvr>
+</p:notes>
+</file>
+
+<file path=ppt/notesSlides/notesSlide12.xml><?xml version="1.0" encoding="utf-8"?>
+<p:notes xmlns:a="http://schemas.openxmlformats.org/drawingml/2006/main" xmlns:p="http://schemas.openxmlformats.org/presentationml/2006/main" xmlns:r="http://schemas.openxmlformats.org/officeDocument/2006/relationships">
+  <p:cSld>
+    <p:spTree>
+      <p:nvGrpSpPr>
+        <p:cNvPr id="1" name=""/>
+        <p:cNvGrpSpPr/>
+        <p:nvPr/>
+      </p:nvGrpSpPr>
+      <p:grpSpPr>
+        <a:xfrm>
+          <a:off x="0" y="0"/>
+          <a:ext cx="0" cy="0"/>
+          <a:chOff x="0" y="0"/>
+          <a:chExt cx="0" cy="0"/>
+        </a:xfrm>
+      </p:grpSpPr>
+      <p:sp>
+        <p:nvSpPr>
+          <p:cNvPr id="2" name="Slide Image Placeholder 1"/>
+          <p:cNvSpPr>
+            <a:spLocks noGrp="1"/>
+          </p:cNvSpPr>
+          <p:nvPr>
+            <p:ph type="sldImg" idx="2"/>
+          </p:nvPr>
+        </p:nvSpPr>
+        <p:spPr/>
+      </p:sp>
+      <p:sp>
+        <p:nvSpPr>
+          <p:cNvPr id="3" name="Notes Placeholder 2"/>
+          <p:cNvSpPr>
+            <a:spLocks noGrp="1"/>
+          </p:cNvSpPr>
+          <p:nvPr>
+            <p:ph type="body" idx="3" sz="quarter"/>
+          </p:nvPr>
+        </p:nvSpPr>
+        <p:spPr/>
+        <p:txBody>
+          <a:bodyPr/>
+          <a:lstStyle/>
+          <a:p>
+            <a:r>
+              <a:t>后续收尾分四块：机制关联分析、抑菌实验验证、结果整理，以及论文撰写与预答辩准备。这些工作不再涉及大规模数据生产。</a:t>
+            </a:r>
+          </a:p>
+        </p:txBody>
+      </p:sp>
+      <p:sp>
+        <p:nvSpPr>
+          <p:cNvPr id="4" name="Slide Number Placeholder 3"/>
+          <p:cNvSpPr>
+            <a:spLocks noGrp="1"/>
+          </p:cNvSpPr>
+          <p:nvPr>
+            <p:ph type="sldNum" idx="5" sz="quarter"/>
+          </p:nvPr>
+        </p:nvSpPr>
+        <p:spPr/>
+      </p:sp>
+    </p:spTree>
+  </p:cSld>
+  <p:clrMapOvr>
+    <a:masterClrMapping/>
+  </p:clrMapOvr>
+</p:notes>
+</file>
+
+<file path=ppt/notesSlides/notesSlide13.xml><?xml version="1.0" encoding="utf-8"?>
+<p:notes xmlns:a="http://schemas.openxmlformats.org/drawingml/2006/main" xmlns:p="http://schemas.openxmlformats.org/presentationml/2006/main" xmlns:r="http://schemas.openxmlformats.org/officeDocument/2006/relationships">
+  <p:cSld>
+    <p:spTree>
+      <p:nvGrpSpPr>
+        <p:cNvPr id="1" name=""/>
+        <p:cNvGrpSpPr/>
+        <p:nvPr/>
+      </p:nvGrpSpPr>
+      <p:grpSpPr>
+        <a:xfrm>
+          <a:off x="0" y="0"/>
+          <a:ext cx="0" cy="0"/>
+          <a:chOff x="0" y="0"/>
+          <a:chExt cx="0" cy="0"/>
+        </a:xfrm>
+      </p:grpSpPr>
+      <p:sp>
+        <p:nvSpPr>
+          <p:cNvPr id="2" name="Slide Image Placeholder 1"/>
+          <p:cNvSpPr>
+            <a:spLocks noGrp="1"/>
+          </p:cNvSpPr>
+          <p:nvPr>
+            <p:ph type="sldImg" idx="2"/>
+          </p:nvPr>
+        </p:nvSpPr>
+        <p:spPr/>
+      </p:sp>
+      <p:sp>
+        <p:nvSpPr>
+          <p:cNvPr id="3" name="Notes Placeholder 2"/>
+          <p:cNvSpPr>
+            <a:spLocks noGrp="1"/>
+          </p:cNvSpPr>
+          <p:nvPr>
+            <p:ph type="body" idx="3" sz="quarter"/>
+          </p:nvPr>
+        </p:nvSpPr>
+        <p:spPr/>
+        <p:txBody>
+          <a:bodyPr/>
+          <a:lstStyle/>
+          <a:p>
+            <a:r>
+              <a:t>与开题计划对照：数据准备、候选肽挖掘、差异分析都已按计划完成，差异分析还增加了宏蛋白组去重；模型方案由自建模型调整为三个已发表模型协同预测；机制与验证部分即将开展。</a:t>
+            </a:r>
+          </a:p>
+        </p:txBody>
+      </p:sp>
+      <p:sp>
+        <p:nvSpPr>
+          <p:cNvPr id="4" name="Slide Number Placeholder 3"/>
+          <p:cNvSpPr>
+            <a:spLocks noGrp="1"/>
+          </p:cNvSpPr>
+          <p:nvPr>
+            <p:ph type="sldNum" idx="5" sz="quarter"/>
+          </p:nvPr>
+        </p:nvSpPr>
+        <p:spPr/>
+      </p:sp>
+    </p:spTree>
+  </p:cSld>
+  <p:clrMapOvr>
+    <a:masterClrMapping/>
+  </p:clrMapOvr>
+</p:notes>
+</file>
+
+<file path=ppt/notesSlides/notesSlide14.xml><?xml version="1.0" encoding="utf-8"?>
+<p:notes xmlns:a="http://schemas.openxmlformats.org/drawingml/2006/main" xmlns:p="http://schemas.openxmlformats.org/presentationml/2006/main" xmlns:r="http://schemas.openxmlformats.org/officeDocument/2006/relationships">
+  <p:cSld>
+    <p:spTree>
+      <p:nvGrpSpPr>
+        <p:cNvPr id="1" name=""/>
+        <p:cNvGrpSpPr/>
+        <p:nvPr/>
+      </p:nvGrpSpPr>
+      <p:grpSpPr>
+        <a:xfrm>
+          <a:off x="0" y="0"/>
+          <a:ext cx="0" cy="0"/>
+          <a:chOff x="0" y="0"/>
+          <a:chExt cx="0" cy="0"/>
+        </a:xfrm>
+      </p:grpSpPr>
+      <p:sp>
+        <p:nvSpPr>
+          <p:cNvPr id="2" name="Slide Image Placeholder 1"/>
+          <p:cNvSpPr>
+            <a:spLocks noGrp="1"/>
+          </p:cNvSpPr>
+          <p:nvPr>
+            <p:ph type="sldImg" idx="2"/>
+          </p:nvPr>
+        </p:nvSpPr>
+        <p:spPr/>
+      </p:sp>
+      <p:sp>
+        <p:nvSpPr>
+          <p:cNvPr id="3" name="Notes Placeholder 2"/>
+          <p:cNvSpPr>
+            <a:spLocks noGrp="1"/>
+          </p:cNvSpPr>
+          <p:nvPr>
+            <p:ph type="body" idx="3" sz="quarter"/>
+          </p:nvPr>
+        </p:nvSpPr>
+        <p:spPr/>
+        <p:txBody>
+          <a:bodyPr/>
+          <a:lstStyle/>
+          <a:p>
+            <a:r>
+              <a:t>目前存在的问题有三点：预测的假阳性风险、部分样本缺少参考基因组、机制关联的证据强度有限，各自都有对应的处理办法，不影响整体进度。</a:t>
+            </a:r>
+          </a:p>
+        </p:txBody>
+      </p:sp>
+      <p:sp>
+        <p:nvSpPr>
+          <p:cNvPr id="4" name="Slide Number Placeholder 3"/>
+          <p:cNvSpPr>
+            <a:spLocks noGrp="1"/>
+          </p:cNvSpPr>
+          <p:nvPr>
+            <p:ph type="sldNum" idx="5" sz="quarter"/>
+          </p:nvPr>
+        </p:nvSpPr>
+        <p:spPr/>
+      </p:sp>
+    </p:spTree>
+  </p:cSld>
+  <p:clrMapOvr>
+    <a:masterClrMapping/>
+  </p:clrMapOvr>
+</p:notes>
+</file>
+
+<file path=ppt/notesSlides/notesSlide15.xml><?xml version="1.0" encoding="utf-8"?>
+<p:notes xmlns:a="http://schemas.openxmlformats.org/drawingml/2006/main" xmlns:p="http://schemas.openxmlformats.org/presentationml/2006/main" xmlns:r="http://schemas.openxmlformats.org/officeDocument/2006/relationships">
+  <p:cSld>
+    <p:spTree>
+      <p:nvGrpSpPr>
+        <p:cNvPr id="1" name=""/>
+        <p:cNvGrpSpPr/>
+        <p:nvPr/>
+      </p:nvGrpSpPr>
+      <p:grpSpPr>
+        <a:xfrm>
+          <a:off x="0" y="0"/>
+          <a:ext cx="0" cy="0"/>
+          <a:chOff x="0" y="0"/>
+          <a:chExt cx="0" cy="0"/>
+        </a:xfrm>
+      </p:grpSpPr>
+      <p:sp>
+        <p:nvSpPr>
+          <p:cNvPr id="2" name="Slide Image Placeholder 1"/>
+          <p:cNvSpPr>
+            <a:spLocks noGrp="1"/>
+          </p:cNvSpPr>
+          <p:nvPr>
+            <p:ph type="sldImg" idx="2"/>
+          </p:nvPr>
+        </p:nvSpPr>
+        <p:spPr/>
+      </p:sp>
+      <p:sp>
+        <p:nvSpPr>
+          <p:cNvPr id="3" name="Notes Placeholder 2"/>
+          <p:cNvSpPr>
+            <a:spLocks noGrp="1"/>
+          </p:cNvSpPr>
+          <p:nvPr>
+            <p:ph type="body" idx="3" sz="quarter"/>
+          </p:nvPr>
+        </p:nvSpPr>
+        <p:spPr/>
+        <p:txBody>
+          <a:bodyPr/>
+          <a:lstStyle/>
+          <a:p>
+            <a:r>
+              <a:t>预期成果包括：一套可复用的分析流程、健康人与各阶段特有的候选抗菌肽清单、机制关联的分析结果、抑菌活性的初步证据，以及一篇投稿论文与学位论文。</a:t>
+            </a:r>
+          </a:p>
+        </p:txBody>
+      </p:sp>
+      <p:sp>
+        <p:nvSpPr>
+          <p:cNvPr id="4" name="Slide Number Placeholder 3"/>
+          <p:cNvSpPr>
+            <a:spLocks noGrp="1"/>
+          </p:cNvSpPr>
+          <p:nvPr>
+            <p:ph type="sldNum" idx="5" sz="quarter"/>
+          </p:nvPr>
+        </p:nvSpPr>
+        <p:spPr/>
+      </p:sp>
+    </p:spTree>
+  </p:cSld>
+  <p:clrMapOvr>
+    <a:masterClrMapping/>
+  </p:clrMapOvr>
+</p:notes>
+</file>
+
+<file path=ppt/notesSlides/notesSlide16.xml><?xml version="1.0" encoding="utf-8"?>
+<p:notes xmlns:a="http://schemas.openxmlformats.org/drawingml/2006/main" xmlns:p="http://schemas.openxmlformats.org/presentationml/2006/main" xmlns:r="http://schemas.openxmlformats.org/officeDocument/2006/relationships">
+  <p:cSld>
+    <p:spTree>
+      <p:nvGrpSpPr>
+        <p:cNvPr id="1" name=""/>
+        <p:cNvGrpSpPr/>
+        <p:nvPr/>
+      </p:nvGrpSpPr>
+      <p:grpSpPr>
+        <a:xfrm>
+          <a:off x="0" y="0"/>
+          <a:ext cx="0" cy="0"/>
+          <a:chOff x="0" y="0"/>
+          <a:chExt cx="0" cy="0"/>
+        </a:xfrm>
+      </p:grpSpPr>
+      <p:sp>
+        <p:nvSpPr>
+          <p:cNvPr id="2" name="Slide Image Placeholder 1"/>
+          <p:cNvSpPr>
+            <a:spLocks noGrp="1"/>
+          </p:cNvSpPr>
+          <p:nvPr>
+            <p:ph type="sldImg" idx="2"/>
+          </p:nvPr>
+        </p:nvSpPr>
+        <p:spPr/>
+      </p:sp>
+      <p:sp>
+        <p:nvSpPr>
+          <p:cNvPr id="3" name="Notes Placeholder 2"/>
+          <p:cNvSpPr>
+            <a:spLocks noGrp="1"/>
+          </p:cNvSpPr>
+          <p:nvPr>
+            <p:ph type="body" idx="3" sz="quarter"/>
+          </p:nvPr>
+        </p:nvSpPr>
+        <p:spPr/>
+        <p:txBody>
+          <a:bodyPr/>
+          <a:lstStyle/>
+          <a:p>
+            <a:r>
+              <a:t>我的汇报到此结束，恳请各位老师批评指正，谢谢！</a:t>
+            </a:r>
+          </a:p>
+        </p:txBody>
+      </p:sp>
+      <p:sp>
+        <p:nvSpPr>
+          <p:cNvPr id="4" name="Slide Number Placeholder 3"/>
+          <p:cNvSpPr>
+            <a:spLocks noGrp="1"/>
+          </p:cNvSpPr>
+          <p:nvPr>
+            <p:ph type="sldNum" idx="5" sz="quarter"/>
+          </p:nvPr>
+        </p:nvSpPr>
+        <p:spPr/>
+      </p:sp>
+    </p:spTree>
+  </p:cSld>
+  <p:clrMapOvr>
+    <a:masterClrMapping/>
+  </p:clrMapOvr>
+</p:notes>
+</file>
+
+<file path=ppt/notesSlides/notesSlide2.xml><?xml version="1.0" encoding="utf-8"?>
+<p:notes xmlns:a="http://schemas.openxmlformats.org/drawingml/2006/main" xmlns:p="http://schemas.openxmlformats.org/presentationml/2006/main" xmlns:r="http://schemas.openxmlformats.org/officeDocument/2006/relationships">
+  <p:cSld>
+    <p:spTree>
+      <p:nvGrpSpPr>
+        <p:cNvPr id="1" name=""/>
+        <p:cNvGrpSpPr/>
+        <p:nvPr/>
+      </p:nvGrpSpPr>
+      <p:grpSpPr>
+        <a:xfrm>
+          <a:off x="0" y="0"/>
+          <a:ext cx="0" cy="0"/>
+          <a:chOff x="0" y="0"/>
+          <a:chExt cx="0" cy="0"/>
+        </a:xfrm>
+      </p:grpSpPr>
+      <p:sp>
+        <p:nvSpPr>
+          <p:cNvPr id="2" name="Slide Image Placeholder 1"/>
+          <p:cNvSpPr>
+            <a:spLocks noGrp="1"/>
+          </p:cNvSpPr>
+          <p:nvPr>
+            <p:ph type="sldImg" idx="2"/>
+          </p:nvPr>
+        </p:nvSpPr>
+        <p:spPr/>
+      </p:sp>
+      <p:sp>
+        <p:nvSpPr>
+          <p:cNvPr id="3" name="Notes Placeholder 2"/>
+          <p:cNvSpPr>
+            <a:spLocks noGrp="1"/>
+          </p:cNvSpPr>
+          <p:nvPr>
+            <p:ph type="body" idx="3" sz="quarter"/>
+          </p:nvPr>
+        </p:nvSpPr>
+        <p:spPr/>
+        <p:txBody>
+          <a:bodyPr/>
+          <a:lstStyle/>
+          <a:p>
+            <a:r>
+              <a:t>汇报分六部分：先说整体思路，再依次说明已完成的数据与预测工作、差异分析与去重工作，然后是下一步的机制关联与抑菌实验，最后是进度与安排。</a:t>
+            </a:r>
+          </a:p>
+        </p:txBody>
+      </p:sp>
+      <p:sp>
+        <p:nvSpPr>
+          <p:cNvPr id="4" name="Slide Number Placeholder 3"/>
+          <p:cNvSpPr>
+            <a:spLocks noGrp="1"/>
+          </p:cNvSpPr>
+          <p:nvPr>
+            <p:ph type="sldNum" idx="5" sz="quarter"/>
+          </p:nvPr>
+        </p:nvSpPr>
+        <p:spPr/>
+      </p:sp>
+    </p:spTree>
+  </p:cSld>
+  <p:clrMapOvr>
+    <a:masterClrMapping/>
+  </p:clrMapOvr>
+</p:notes>
+</file>
+
+<file path=ppt/notesSlides/notesSlide3.xml><?xml version="1.0" encoding="utf-8"?>
+<p:notes xmlns:a="http://schemas.openxmlformats.org/drawingml/2006/main" xmlns:p="http://schemas.openxmlformats.org/presentationml/2006/main" xmlns:r="http://schemas.openxmlformats.org/officeDocument/2006/relationships">
+  <p:cSld>
+    <p:spTree>
+      <p:nvGrpSpPr>
+        <p:cNvPr id="1" name=""/>
+        <p:cNvGrpSpPr/>
+        <p:nvPr/>
+      </p:nvGrpSpPr>
+      <p:grpSpPr>
+        <a:xfrm>
+          <a:off x="0" y="0"/>
+          <a:ext cx="0" cy="0"/>
+          <a:chOff x="0" y="0"/>
+          <a:chExt cx="0" cy="0"/>
+        </a:xfrm>
+      </p:grpSpPr>
+      <p:sp>
+        <p:nvSpPr>
+          <p:cNvPr id="2" name="Slide Image Placeholder 1"/>
+          <p:cNvSpPr>
+            <a:spLocks noGrp="1"/>
+          </p:cNvSpPr>
+          <p:nvPr>
+            <p:ph type="sldImg" idx="2"/>
+          </p:nvPr>
+        </p:nvSpPr>
+        <p:spPr/>
+      </p:sp>
+      <p:sp>
+        <p:nvSpPr>
+          <p:cNvPr id="3" name="Notes Placeholder 2"/>
+          <p:cNvSpPr>
+            <a:spLocks noGrp="1"/>
+          </p:cNvSpPr>
+          <p:nvPr>
+            <p:ph type="body" idx="3" sz="quarter"/>
+          </p:nvPr>
+        </p:nvSpPr>
+        <p:spPr/>
+        <p:txBody>
+          <a:bodyPr/>
+          <a:lstStyle/>
+          <a:p>
+            <a:r>
+              <a:t>整个研究可以概括为八步：前四步是宏基因组数据、参考集、短肽库和三模型预测，属于数据与预测阶段；后四步是分阶段差异分析、宏蛋白组去重、特有抗菌肽筛选以及机制关联与验证。目前数据与预测阶段已全部完成，分阶段差异分析与宏蛋白组去重也已基本完成，工作重心转到特有抗菌肽的机制关联与极简抑菌实验验证。</a:t>
+            </a:r>
+          </a:p>
+        </p:txBody>
+      </p:sp>
+      <p:sp>
+        <p:nvSpPr>
+          <p:cNvPr id="4" name="Slide Number Placeholder 3"/>
+          <p:cNvSpPr>
+            <a:spLocks noGrp="1"/>
+          </p:cNvSpPr>
+          <p:nvPr>
+            <p:ph type="sldNum" idx="5" sz="quarter"/>
+          </p:nvPr>
+        </p:nvSpPr>
+        <p:spPr/>
+      </p:sp>
+    </p:spTree>
+  </p:cSld>
+  <p:clrMapOvr>
+    <a:masterClrMapping/>
+  </p:clrMapOvr>
+</p:notes>
+</file>
+
+<file path=ppt/notesSlides/notesSlide4.xml><?xml version="1.0" encoding="utf-8"?>
+<p:notes xmlns:a="http://schemas.openxmlformats.org/drawingml/2006/main" xmlns:p="http://schemas.openxmlformats.org/presentationml/2006/main" xmlns:r="http://schemas.openxmlformats.org/officeDocument/2006/relationships">
+  <p:cSld>
+    <p:spTree>
+      <p:nvGrpSpPr>
+        <p:cNvPr id="1" name=""/>
+        <p:cNvGrpSpPr/>
+        <p:nvPr/>
+      </p:nvGrpSpPr>
+      <p:grpSpPr>
+        <a:xfrm>
+          <a:off x="0" y="0"/>
+          <a:ext cx="0" cy="0"/>
+          <a:chOff x="0" y="0"/>
+          <a:chExt cx="0" cy="0"/>
+        </a:xfrm>
+      </p:grpSpPr>
+      <p:sp>
+        <p:nvSpPr>
+          <p:cNvPr id="2" name="Slide Image Placeholder 1"/>
+          <p:cNvSpPr>
+            <a:spLocks noGrp="1"/>
+          </p:cNvSpPr>
+          <p:nvPr>
+            <p:ph type="sldImg" idx="2"/>
+          </p:nvPr>
+        </p:nvSpPr>
+        <p:spPr/>
+      </p:sp>
+      <p:sp>
+        <p:nvSpPr>
+          <p:cNvPr id="3" name="Notes Placeholder 2"/>
+          <p:cNvSpPr>
+            <a:spLocks noGrp="1"/>
+          </p:cNvSpPr>
+          <p:nvPr>
+            <p:ph type="body" idx="3" sz="quarter"/>
+          </p:nvPr>
+        </p:nvSpPr>
+        <p:spPr/>
+        <p:txBody>
+          <a:bodyPr/>
+          <a:lstStyle/>
+          <a:p>
+            <a:r>
+              <a:t>研究背景有三点：一是 AD 与肠—脑轴的关联已被广泛报道；二是微生物基因组编码的短肽中可能包含抗菌肽，是潜在效应分子；三是现有研究缺少面向 AD 人群、按认知阶段分层的分析。由此提出科学问题。</a:t>
+            </a:r>
+          </a:p>
+        </p:txBody>
+      </p:sp>
+      <p:sp>
+        <p:nvSpPr>
+          <p:cNvPr id="4" name="Slide Number Placeholder 3"/>
+          <p:cNvSpPr>
+            <a:spLocks noGrp="1"/>
+          </p:cNvSpPr>
+          <p:nvPr>
+            <p:ph type="sldNum" idx="5" sz="quarter"/>
+          </p:nvPr>
+        </p:nvSpPr>
+        <p:spPr/>
+      </p:sp>
+    </p:spTree>
+  </p:cSld>
+  <p:clrMapOvr>
+    <a:masterClrMapping/>
+  </p:clrMapOvr>
+</p:notes>
+</file>
+
+<file path=ppt/notesSlides/notesSlide5.xml><?xml version="1.0" encoding="utf-8"?>
+<p:notes xmlns:a="http://schemas.openxmlformats.org/drawingml/2006/main" xmlns:p="http://schemas.openxmlformats.org/presentationml/2006/main" xmlns:r="http://schemas.openxmlformats.org/officeDocument/2006/relationships">
+  <p:cSld>
+    <p:spTree>
+      <p:nvGrpSpPr>
+        <p:cNvPr id="1" name=""/>
+        <p:cNvGrpSpPr/>
+        <p:nvPr/>
+      </p:nvGrpSpPr>
+      <p:grpSpPr>
+        <a:xfrm>
+          <a:off x="0" y="0"/>
+          <a:ext cx="0" cy="0"/>
+          <a:chOff x="0" y="0"/>
+          <a:chExt cx="0" cy="0"/>
+        </a:xfrm>
+      </p:grpSpPr>
+      <p:sp>
+        <p:nvSpPr>
+          <p:cNvPr id="2" name="Slide Image Placeholder 1"/>
+          <p:cNvSpPr>
+            <a:spLocks noGrp="1"/>
+          </p:cNvSpPr>
+          <p:nvPr>
+            <p:ph type="sldImg" idx="2"/>
+          </p:nvPr>
+        </p:nvSpPr>
+        <p:spPr/>
+      </p:sp>
+      <p:sp>
+        <p:nvSpPr>
+          <p:cNvPr id="3" name="Notes Placeholder 2"/>
+          <p:cNvSpPr>
+            <a:spLocks noGrp="1"/>
+          </p:cNvSpPr>
+          <p:nvPr>
+            <p:ph type="body" idx="3" sz="quarter"/>
+          </p:nvPr>
+        </p:nvSpPr>
+        <p:spPr/>
+        <p:txBody>
+          <a:bodyPr/>
+          <a:lstStyle/>
+          <a:p>
+            <a:r>
+              <a:t>第一步与第二步已经完成：全队列的宏基因组数据完成了统一处理，得到微生物基因组参考集，并据此完成短开放阅读框预测，构建了覆盖全队列、可追溯的非冗余短肽库。</a:t>
+            </a:r>
+          </a:p>
+        </p:txBody>
+      </p:sp>
+      <p:sp>
+        <p:nvSpPr>
+          <p:cNvPr id="4" name="Slide Number Placeholder 3"/>
+          <p:cNvSpPr>
+            <a:spLocks noGrp="1"/>
+          </p:cNvSpPr>
+          <p:nvPr>
+            <p:ph type="sldNum" idx="5" sz="quarter"/>
+          </p:nvPr>
+        </p:nvSpPr>
+        <p:spPr/>
+      </p:sp>
+    </p:spTree>
+  </p:cSld>
+  <p:clrMapOvr>
+    <a:masterClrMapping/>
+  </p:clrMapOvr>
+</p:notes>
+</file>
+
+<file path=ppt/notesSlides/notesSlide6.xml><?xml version="1.0" encoding="utf-8"?>
+<p:notes xmlns:a="http://schemas.openxmlformats.org/drawingml/2006/main" xmlns:p="http://schemas.openxmlformats.org/presentationml/2006/main" xmlns:r="http://schemas.openxmlformats.org/officeDocument/2006/relationships">
+  <p:cSld>
+    <p:spTree>
+      <p:nvGrpSpPr>
+        <p:cNvPr id="1" name=""/>
+        <p:cNvGrpSpPr/>
+        <p:nvPr/>
+      </p:nvGrpSpPr>
+      <p:grpSpPr>
+        <a:xfrm>
+          <a:off x="0" y="0"/>
+          <a:ext cx="0" cy="0"/>
+          <a:chOff x="0" y="0"/>
+          <a:chExt cx="0" cy="0"/>
+        </a:xfrm>
+      </p:grpSpPr>
+      <p:sp>
+        <p:nvSpPr>
+          <p:cNvPr id="2" name="Slide Image Placeholder 1"/>
+          <p:cNvSpPr>
+            <a:spLocks noGrp="1"/>
+          </p:cNvSpPr>
+          <p:nvPr>
+            <p:ph type="sldImg" idx="2"/>
+          </p:nvPr>
+        </p:nvSpPr>
+        <p:spPr/>
+      </p:sp>
+      <p:sp>
+        <p:nvSpPr>
+          <p:cNvPr id="3" name="Notes Placeholder 2"/>
+          <p:cNvSpPr>
+            <a:spLocks noGrp="1"/>
+          </p:cNvSpPr>
+          <p:nvPr>
+            <p:ph type="body" idx="3" sz="quarter"/>
+          </p:nvPr>
+        </p:nvSpPr>
+        <p:spPr/>
+        <p:txBody>
+          <a:bodyPr/>
+          <a:lstStyle/>
+          <a:p>
+            <a:r>
+              <a:t>第三个环节是候选抗菌肽预测。这里采用 Attention、LSTM、BERT 三个深度学习模型分别预测，只有三者一致判为阳性的序列才纳入候选集合，以提高候选集的可信度。这一步骤已经完成。</a:t>
+            </a:r>
+          </a:p>
+        </p:txBody>
+      </p:sp>
+      <p:sp>
+        <p:nvSpPr>
+          <p:cNvPr id="4" name="Slide Number Placeholder 3"/>
+          <p:cNvSpPr>
+            <a:spLocks noGrp="1"/>
+          </p:cNvSpPr>
+          <p:nvPr>
+            <p:ph type="sldNum" idx="5" sz="quarter"/>
+          </p:nvPr>
+        </p:nvSpPr>
+        <p:spPr/>
+      </p:sp>
+    </p:spTree>
+  </p:cSld>
+  <p:clrMapOvr>
+    <a:masterClrMapping/>
+  </p:clrMapOvr>
+</p:notes>
+</file>
+
+<file path=ppt/notesSlides/notesSlide7.xml><?xml version="1.0" encoding="utf-8"?>
+<p:notes xmlns:a="http://schemas.openxmlformats.org/drawingml/2006/main" xmlns:p="http://schemas.openxmlformats.org/presentationml/2006/main" xmlns:r="http://schemas.openxmlformats.org/officeDocument/2006/relationships">
+  <p:cSld>
+    <p:spTree>
+      <p:nvGrpSpPr>
+        <p:cNvPr id="1" name=""/>
+        <p:cNvGrpSpPr/>
+        <p:nvPr/>
+      </p:nvGrpSpPr>
+      <p:grpSpPr>
+        <a:xfrm>
+          <a:off x="0" y="0"/>
+          <a:ext cx="0" cy="0"/>
+          <a:chOff x="0" y="0"/>
+          <a:chExt cx="0" cy="0"/>
+        </a:xfrm>
+      </p:grpSpPr>
+      <p:sp>
+        <p:nvSpPr>
+          <p:cNvPr id="2" name="Slide Image Placeholder 1"/>
+          <p:cNvSpPr>
+            <a:spLocks noGrp="1"/>
+          </p:cNvSpPr>
+          <p:nvPr>
+            <p:ph type="sldImg" idx="2"/>
+          </p:nvPr>
+        </p:nvSpPr>
+        <p:spPr/>
+      </p:sp>
+      <p:sp>
+        <p:nvSpPr>
+          <p:cNvPr id="3" name="Notes Placeholder 2"/>
+          <p:cNvSpPr>
+            <a:spLocks noGrp="1"/>
+          </p:cNvSpPr>
+          <p:nvPr>
+            <p:ph type="body" idx="3" sz="quarter"/>
+          </p:nvPr>
+        </p:nvSpPr>
+        <p:spPr/>
+        <p:txBody>
+          <a:bodyPr/>
+          <a:lstStyle/>
+          <a:p>
+            <a:r>
+              <a:t>第四个环节是分阶段差异分析：把队列按认知阶段分组，比较各阶段与健康人群之间候选抗菌肽的丰度与组成差异，得到一批随病程变化的候选抗菌肽。这一步骤也已经完成。</a:t>
+            </a:r>
+          </a:p>
+        </p:txBody>
+      </p:sp>
+      <p:sp>
+        <p:nvSpPr>
+          <p:cNvPr id="4" name="Slide Number Placeholder 3"/>
+          <p:cNvSpPr>
+            <a:spLocks noGrp="1"/>
+          </p:cNvSpPr>
+          <p:nvPr>
+            <p:ph type="sldNum" idx="5" sz="quarter"/>
+          </p:nvPr>
+        </p:nvSpPr>
+        <p:spPr/>
+      </p:sp>
+    </p:spTree>
+  </p:cSld>
+  <p:clrMapOvr>
+    <a:masterClrMapping/>
+  </p:clrMapOvr>
+</p:notes>
+</file>
+
+<file path=ppt/notesSlides/notesSlide8.xml><?xml version="1.0" encoding="utf-8"?>
+<p:notes xmlns:a="http://schemas.openxmlformats.org/drawingml/2006/main" xmlns:p="http://schemas.openxmlformats.org/presentationml/2006/main" xmlns:r="http://schemas.openxmlformats.org/officeDocument/2006/relationships">
+  <p:cSld>
+    <p:spTree>
+      <p:nvGrpSpPr>
+        <p:cNvPr id="1" name=""/>
+        <p:cNvGrpSpPr/>
+        <p:nvPr/>
+      </p:nvGrpSpPr>
+      <p:grpSpPr>
+        <a:xfrm>
+          <a:off x="0" y="0"/>
+          <a:ext cx="0" cy="0"/>
+          <a:chOff x="0" y="0"/>
+          <a:chExt cx="0" cy="0"/>
+        </a:xfrm>
+      </p:grpSpPr>
+      <p:sp>
+        <p:nvSpPr>
+          <p:cNvPr id="2" name="Slide Image Placeholder 1"/>
+          <p:cNvSpPr>
+            <a:spLocks noGrp="1"/>
+          </p:cNvSpPr>
+          <p:nvPr>
+            <p:ph type="sldImg" idx="2"/>
+          </p:nvPr>
+        </p:nvSpPr>
+        <p:spPr/>
+      </p:sp>
+      <p:sp>
+        <p:nvSpPr>
+          <p:cNvPr id="3" name="Notes Placeholder 2"/>
+          <p:cNvSpPr>
+            <a:spLocks noGrp="1"/>
+          </p:cNvSpPr>
+          <p:nvPr>
+            <p:ph type="body" idx="3" sz="quarter"/>
+          </p:nvPr>
+        </p:nvSpPr>
+        <p:spPr/>
+        <p:txBody>
+          <a:bodyPr/>
+          <a:lstStyle/>
+          <a:p>
+            <a:r>
+              <a:t>差异分析之后，引入宏蛋白组的表达证据做二次去重：只保留在蛋白层面真实存在并可检出的抗菌肽，再通过组内共有、组间特有的比较，得到健康人群特有与各疾病阶段特有的抗菌肽清单。这一步同样已经完成。</a:t>
+            </a:r>
+          </a:p>
+        </p:txBody>
+      </p:sp>
+      <p:sp>
+        <p:nvSpPr>
+          <p:cNvPr id="4" name="Slide Number Placeholder 3"/>
+          <p:cNvSpPr>
+            <a:spLocks noGrp="1"/>
+          </p:cNvSpPr>
+          <p:nvPr>
+            <p:ph type="sldNum" idx="5" sz="quarter"/>
+          </p:nvPr>
+        </p:nvSpPr>
+        <p:spPr/>
+      </p:sp>
+    </p:spTree>
+  </p:cSld>
+  <p:clrMapOvr>
+    <a:masterClrMapping/>
+  </p:clrMapOvr>
+</p:notes>
+</file>
+
+<file path=ppt/notesSlides/notesSlide9.xml><?xml version="1.0" encoding="utf-8"?>
+<p:notes xmlns:a="http://schemas.openxmlformats.org/drawingml/2006/main" xmlns:p="http://schemas.openxmlformats.org/presentationml/2006/main" xmlns:r="http://schemas.openxmlformats.org/officeDocument/2006/relationships">
+  <p:cSld>
+    <p:spTree>
+      <p:nvGrpSpPr>
+        <p:cNvPr id="1" name=""/>
+        <p:cNvGrpSpPr/>
+        <p:nvPr/>
+      </p:nvGrpSpPr>
+      <p:grpSpPr>
+        <a:xfrm>
+          <a:off x="0" y="0"/>
+          <a:ext cx="0" cy="0"/>
+          <a:chOff x="0" y="0"/>
+          <a:chExt cx="0" cy="0"/>
+        </a:xfrm>
+      </p:grpSpPr>
+      <p:sp>
+        <p:nvSpPr>
+          <p:cNvPr id="2" name="Slide Image Placeholder 1"/>
+          <p:cNvSpPr>
+            <a:spLocks noGrp="1"/>
+          </p:cNvSpPr>
+          <p:nvPr>
+            <p:ph type="sldImg" idx="2"/>
+          </p:nvPr>
+        </p:nvSpPr>
+        <p:spPr/>
+      </p:sp>
+      <p:sp>
+        <p:nvSpPr>
+          <p:cNvPr id="3" name="Notes Placeholder 2"/>
+          <p:cNvSpPr>
+            <a:spLocks noGrp="1"/>
+          </p:cNvSpPr>
+          <p:nvPr>
+            <p:ph type="body" idx="3" sz="quarter"/>
+          </p:nvPr>
+        </p:nvSpPr>
+        <p:spPr/>
+        <p:txBody>
+          <a:bodyPr/>
+          <a:lstStyle/>
+          <a:p>
+            <a:r>
+              <a:t>接下来是与发病机制的关联分析。参照乙酰胆碱酯酶与 β-淀粉样肽复合物分子模拟研究的思路，从三个方向考察：与 Aβ 的相互作用、与 AChE 外周阴离子位点的结合，以及免疫与炎症通路。目前这一步正在进行。</a:t>
+            </a:r>
+          </a:p>
+        </p:txBody>
+      </p:sp>
+      <p:sp>
+        <p:nvSpPr>
+          <p:cNvPr id="4" name="Slide Number Placeholder 3"/>
+          <p:cNvSpPr>
+            <a:spLocks noGrp="1"/>
+          </p:cNvSpPr>
+          <p:nvPr>
+            <p:ph type="sldNum" idx="5" sz="quarter"/>
+          </p:nvPr>
+        </p:nvSpPr>
+        <p:spPr/>
+      </p:sp>
+    </p:spTree>
+  </p:cSld>
+  <p:clrMapOvr>
+    <a:masterClrMapping/>
+  </p:clrMapOvr>
+</p:notes>
 </file>
 
 <file path=ppt/slideLayouts/slideLayout1.xml><?xml version="1.0" encoding="utf-8"?>
@@ -6648,7 +8118,7 @@
                 <a:ea typeface="微软雅黑"/>
                 <a:cs typeface="Arial"/>
               </a:rPr>
-              <a:t>研究思路：八步走，前三步与预测已完成</a:t>
+              <a:t>研究思路：八步走的整体框架与完成进度</a:t>
             </a:r>
           </a:p>
         </p:txBody>
@@ -9782,4 +11252,324 @@
   </a:objectDefaults>
   <a:extraClrSchemeLst/>
 </a:theme>
+</file>
+
+<file path=ppt/theme/theme2.xml><?xml version="1.0" encoding="utf-8"?>
+<a:theme xmlns:a="http://schemas.openxmlformats.org/drawingml/2006/main" name="Office Theme">
+  <a:themeElements>
+    <a:clrScheme name="Office">
+      <a:dk1>
+        <a:sysClr val="windowText" lastClr="000000"/>
+      </a:dk1>
+      <a:lt1>
+        <a:sysClr val="window" lastClr="FFFFFF"/>
+      </a:lt1>
+      <a:dk2>
+        <a:srgbClr val="1F497D"/>
+      </a:dk2>
+      <a:lt2>
+        <a:srgbClr val="EEECE1"/>
+      </a:lt2>
+      <a:accent1>
+        <a:srgbClr val="4F81BD"/>
+      </a:accent1>
+      <a:accent2>
+        <a:srgbClr val="C0504D"/>
+      </a:accent2>
+      <a:accent3>
+        <a:srgbClr val="9BBB59"/>
+      </a:accent3>
+      <a:accent4>
+        <a:srgbClr val="8064A2"/>
+      </a:accent4>
+      <a:accent5>
+        <a:srgbClr val="4BACC6"/>
+      </a:accent5>
+      <a:accent6>
+        <a:srgbClr val="F79646"/>
+      </a:accent6>
+      <a:hlink>
+        <a:srgbClr val="0000FF"/>
+      </a:hlink>
+      <a:folHlink>
+        <a:srgbClr val="800080"/>
+      </a:folHlink>
+    </a:clrScheme>
+    <a:fontScheme name="Office">
+      <a:majorFont>
+        <a:latin typeface="Calibri"/>
+        <a:ea typeface=""/>
+        <a:cs typeface=""/>
+        <a:font script="Jpan" typeface="ＭＳ Ｐゴシック"/>
+        <a:font script="Hang" typeface="맑은 고딕"/>
+        <a:font script="Hans" typeface="宋体"/>
+        <a:font script="Hant" typeface="新細明體"/>
+        <a:font script="Arab" typeface="Times New Roman"/>
+        <a:font script="Hebr" typeface="Times New Roman"/>
+        <a:font script="Thai" typeface="Angsana New"/>
+        <a:font script="Ethi" typeface="Nyala"/>
+        <a:font script="Beng" typeface="Vrinda"/>
+        <a:font script="Gujr" typeface="Shruti"/>
+        <a:font script="Khmr" typeface="MoolBoran"/>
+        <a:font script="Knda" typeface="Tunga"/>
+        <a:font script="Guru" typeface="Raavi"/>
+        <a:font script="Cans" typeface="Euphemia"/>
+        <a:font script="Cher" typeface="Plantagenet Cherokee"/>
+        <a:font script="Yiii" typeface="Microsoft Yi Baiti"/>
+        <a:font script="Tibt" typeface="Microsoft Himalaya"/>
+        <a:font script="Thaa" typeface="MV Boli"/>
+        <a:font script="Deva" typeface="Mangal"/>
+        <a:font script="Telu" typeface="Gautami"/>
+        <a:font script="Taml" typeface="Latha"/>
+        <a:font script="Syrc" typeface="Estrangelo Edessa"/>
+        <a:font script="Orya" typeface="Kalinga"/>
+        <a:font script="Mlym" typeface="Kartika"/>
+        <a:font script="Laoo" typeface="DokChampa"/>
+        <a:font script="Sinh" typeface="Iskoola Pota"/>
+        <a:font script="Mong" typeface="Mongolian Baiti"/>
+        <a:font script="Viet" typeface="Times New Roman"/>
+        <a:font script="Uigh" typeface="Microsoft Uighur"/>
+        <a:font script="Geor" typeface="Sylfaen"/>
+      </a:majorFont>
+      <a:minorFont>
+        <a:latin typeface="Calibri"/>
+        <a:ea typeface=""/>
+        <a:cs typeface=""/>
+        <a:font script="Jpan" typeface="ＭＳ Ｐゴシック"/>
+        <a:font script="Hang" typeface="맑은 고딕"/>
+        <a:font script="Hans" typeface="宋体"/>
+        <a:font script="Hant" typeface="新細明體"/>
+        <a:font script="Arab" typeface="Arial"/>
+        <a:font script="Hebr" typeface="Arial"/>
+        <a:font script="Thai" typeface="Cordia New"/>
+        <a:font script="Ethi" typeface="Nyala"/>
+        <a:font script="Beng" typeface="Vrinda"/>
+        <a:font script="Gujr" typeface="Shruti"/>
+        <a:font script="Khmr" typeface="DaunPenh"/>
+        <a:font script="Knda" typeface="Tunga"/>
+        <a:font script="Guru" typeface="Raavi"/>
+        <a:font script="Cans" typeface="Euphemia"/>
+        <a:font script="Cher" typeface="Plantagenet Cherokee"/>
+        <a:font script="Yiii" typeface="Microsoft Yi Baiti"/>
+        <a:font script="Tibt" typeface="Microsoft Himalaya"/>
+        <a:font script="Thaa" typeface="MV Boli"/>
+        <a:font script="Deva" typeface="Mangal"/>
+        <a:font script="Telu" typeface="Gautami"/>
+        <a:font script="Taml" typeface="Latha"/>
+        <a:font script="Syrc" typeface="Estrangelo Edessa"/>
+        <a:font script="Orya" typeface="Kalinga"/>
+        <a:font script="Mlym" typeface="Kartika"/>
+        <a:font script="Laoo" typeface="DokChampa"/>
+        <a:font script="Sinh" typeface="Iskoola Pota"/>
+        <a:font script="Mong" typeface="Mongolian Baiti"/>
+        <a:font script="Viet" typeface="Arial"/>
+        <a:font script="Uigh" typeface="Microsoft Uighur"/>
+        <a:font script="Geor" typeface="Sylfaen"/>
+      </a:minorFont>
+    </a:fontScheme>
+    <a:fmtScheme name="Office">
+      <a:fillStyleLst>
+        <a:solidFill>
+          <a:schemeClr val="phClr"/>
+        </a:solidFill>
+        <a:gradFill rotWithShape="1">
+          <a:gsLst>
+            <a:gs pos="0">
+              <a:schemeClr val="phClr">
+                <a:tint val="50000"/>
+                <a:satMod val="300000"/>
+              </a:schemeClr>
+            </a:gs>
+            <a:gs pos="35000">
+              <a:schemeClr val="phClr">
+                <a:tint val="37000"/>
+                <a:satMod val="300000"/>
+              </a:schemeClr>
+            </a:gs>
+            <a:gs pos="100000">
+              <a:schemeClr val="phClr">
+                <a:tint val="15000"/>
+                <a:satMod val="350000"/>
+              </a:schemeClr>
+            </a:gs>
+          </a:gsLst>
+          <a:lin ang="16200000" scaled="1"/>
+        </a:gradFill>
+        <a:gradFill rotWithShape="1">
+          <a:gsLst>
+            <a:gs pos="0">
+              <a:schemeClr val="phClr">
+                <a:tint val="100000"/>
+                <a:shade val="100000"/>
+                <a:satMod val="130000"/>
+              </a:schemeClr>
+            </a:gs>
+            <a:gs pos="100000">
+              <a:schemeClr val="phClr">
+                <a:tint val="50000"/>
+                <a:shade val="100000"/>
+                <a:satMod val="350000"/>
+              </a:schemeClr>
+            </a:gs>
+          </a:gsLst>
+          <a:lin ang="16200000" scaled="0"/>
+        </a:gradFill>
+      </a:fillStyleLst>
+      <a:lnStyleLst>
+        <a:ln w="9525" cap="flat" cmpd="sng" algn="ctr">
+          <a:solidFill>
+            <a:schemeClr val="phClr">
+              <a:shade val="95000"/>
+              <a:satMod val="105000"/>
+            </a:schemeClr>
+          </a:solidFill>
+          <a:prstDash val="solid"/>
+        </a:ln>
+        <a:ln w="25400" cap="flat" cmpd="sng" algn="ctr">
+          <a:solidFill>
+            <a:schemeClr val="phClr"/>
+          </a:solidFill>
+          <a:prstDash val="solid"/>
+        </a:ln>
+        <a:ln w="38100" cap="flat" cmpd="sng" algn="ctr">
+          <a:solidFill>
+            <a:schemeClr val="phClr"/>
+          </a:solidFill>
+          <a:prstDash val="solid"/>
+        </a:ln>
+      </a:lnStyleLst>
+      <a:effectStyleLst>
+        <a:effectStyle>
+          <a:effectLst>
+            <a:outerShdw blurRad="40000" dist="20000" dir="5400000" rotWithShape="0">
+              <a:srgbClr val="000000">
+                <a:alpha val="38000"/>
+              </a:srgbClr>
+            </a:outerShdw>
+          </a:effectLst>
+        </a:effectStyle>
+        <a:effectStyle>
+          <a:effectLst>
+            <a:outerShdw blurRad="40000" dist="23000" dir="5400000" rotWithShape="0">
+              <a:srgbClr val="000000">
+                <a:alpha val="35000"/>
+              </a:srgbClr>
+            </a:outerShdw>
+          </a:effectLst>
+        </a:effectStyle>
+        <a:effectStyle>
+          <a:effectLst>
+            <a:outerShdw blurRad="40000" dist="23000" dir="5400000" rotWithShape="0">
+              <a:srgbClr val="000000">
+                <a:alpha val="35000"/>
+              </a:srgbClr>
+            </a:outerShdw>
+          </a:effectLst>
+          <a:scene3d>
+            <a:camera prst="orthographicFront">
+              <a:rot lat="0" lon="0" rev="0"/>
+            </a:camera>
+            <a:lightRig rig="threePt" dir="t">
+              <a:rot lat="0" lon="0" rev="1200000"/>
+            </a:lightRig>
+          </a:scene3d>
+          <a:sp3d>
+            <a:bevelT w="63500" h="25400"/>
+          </a:sp3d>
+        </a:effectStyle>
+      </a:effectStyleLst>
+      <a:bgFillStyleLst>
+        <a:solidFill>
+          <a:schemeClr val="phClr"/>
+        </a:solidFill>
+        <a:gradFill rotWithShape="1">
+          <a:gsLst>
+            <a:gs pos="0">
+              <a:schemeClr val="phClr">
+                <a:tint val="40000"/>
+                <a:satMod val="350000"/>
+              </a:schemeClr>
+            </a:gs>
+            <a:gs pos="40000">
+              <a:schemeClr val="phClr">
+                <a:tint val="45000"/>
+                <a:shade val="99000"/>
+                <a:satMod val="350000"/>
+              </a:schemeClr>
+            </a:gs>
+            <a:gs pos="100000">
+              <a:schemeClr val="phClr">
+                <a:shade val="20000"/>
+                <a:satMod val="255000"/>
+              </a:schemeClr>
+            </a:gs>
+          </a:gsLst>
+          <a:path path="circle">
+            <a:fillToRect l="50000" t="-80000" r="50000" b="180000"/>
+          </a:path>
+        </a:gradFill>
+        <a:gradFill rotWithShape="1">
+          <a:gsLst>
+            <a:gs pos="0">
+              <a:schemeClr val="phClr">
+                <a:tint val="80000"/>
+                <a:satMod val="300000"/>
+              </a:schemeClr>
+            </a:gs>
+            <a:gs pos="100000">
+              <a:schemeClr val="phClr">
+                <a:shade val="30000"/>
+                <a:satMod val="200000"/>
+              </a:schemeClr>
+            </a:gs>
+          </a:gsLst>
+          <a:path path="circle">
+            <a:fillToRect l="50000" t="50000" r="50000" b="50000"/>
+          </a:path>
+        </a:gradFill>
+      </a:bgFillStyleLst>
+    </a:fmtScheme>
+  </a:themeElements>
+  <a:objectDefaults>
+    <a:spDef>
+      <a:spPr/>
+      <a:bodyPr/>
+      <a:lstStyle/>
+      <a:style>
+        <a:lnRef idx="1">
+          <a:schemeClr val="accent1"/>
+        </a:lnRef>
+        <a:fillRef idx="3">
+          <a:schemeClr val="accent1"/>
+        </a:fillRef>
+        <a:effectRef idx="2">
+          <a:schemeClr val="accent1"/>
+        </a:effectRef>
+        <a:fontRef idx="minor">
+          <a:schemeClr val="lt1"/>
+        </a:fontRef>
+      </a:style>
+    </a:spDef>
+    <a:lnDef>
+      <a:spPr/>
+      <a:bodyPr/>
+      <a:lstStyle/>
+      <a:style>
+        <a:lnRef idx="2">
+          <a:schemeClr val="accent1"/>
+        </a:lnRef>
+        <a:fillRef idx="0">
+          <a:schemeClr val="accent1"/>
+        </a:fillRef>
+        <a:effectRef idx="1">
+          <a:schemeClr val="accent1"/>
+        </a:effectRef>
+        <a:fontRef idx="minor">
+          <a:schemeClr val="tx1"/>
+        </a:fontRef>
+      </a:style>
+    </a:lnDef>
+  </a:objectDefaults>
+  <a:extraClrSchemeLst/>
+</a:theme>
 </file>
</xml_diff>